<commit_message>
improve comments (no feature added)
</commit_message>
<xml_diff>
--- a/Efficiency_calculator/SEM_lapTime_consumption.pptx
+++ b/Efficiency_calculator/SEM_lapTime_consumption.pptx
@@ -224,7 +224,7 @@
           <a:p>
             <a:fld id="{D96A055B-0E81-4EEF-A36B-666997CD7E14}" type="datetimeFigureOut">
               <a:rPr lang="en-GB" smtClean="0"/>
-              <a:t>08/10/2026</a:t>
+              <a:t>09/10/2026</a:t>
             </a:fld>
             <a:endParaRPr lang="en-GB"/>
           </a:p>
@@ -734,7 +734,7 @@
           <a:p>
             <a:fld id="{A962E2B5-AD3A-452B-996C-1D06A125B710}" type="datetime1">
               <a:rPr lang="en-GB" smtClean="0"/>
-              <a:t>08/10/2026</a:t>
+              <a:t>09/10/2026</a:t>
             </a:fld>
             <a:endParaRPr lang="en-GB"/>
           </a:p>
@@ -926,7 +926,7 @@
           <a:p>
             <a:fld id="{CA9A9924-1784-4044-A2E4-3606370E1BB6}" type="datetime1">
               <a:rPr lang="en-GB" smtClean="0"/>
-              <a:t>08/10/2026</a:t>
+              <a:t>09/10/2026</a:t>
             </a:fld>
             <a:endParaRPr lang="en-GB" dirty="0">
               <a:latin typeface="Segoe UI Symbol" panose="020B0502040204020203" pitchFamily="34" charset="0"/>
@@ -1175,7 +1175,7 @@
           <a:p>
             <a:fld id="{30058C10-7476-49B5-8355-BBAFE5754F9E}" type="datetime1">
               <a:rPr lang="en-GB" smtClean="0"/>
-              <a:t>08/10/2026</a:t>
+              <a:t>09/10/2026</a:t>
             </a:fld>
             <a:endParaRPr lang="en-GB" dirty="0">
               <a:latin typeface="Segoe UI Symbol" panose="020B0502040204020203" pitchFamily="34" charset="0"/>
@@ -1606,7 +1606,7 @@
           <a:p>
             <a:fld id="{61067CC1-09C0-4CA6-A28C-A624AFD2E92A}" type="datetime1">
               <a:rPr lang="fr-BE" noProof="0" smtClean="0"/>
-              <a:t>08/10/2026</a:t>
+              <a:t>09-10-26</a:t>
             </a:fld>
             <a:endParaRPr lang="fr-BE" noProof="0" dirty="0">
               <a:latin typeface="Segoe UI Symbol" panose="020B0502040204020203" pitchFamily="34" charset="0"/>
@@ -1911,7 +1911,7 @@
           <a:p>
             <a:fld id="{CA9A9924-1784-4044-A2E4-3606370E1BB6}" type="datetime1">
               <a:rPr lang="fr-BE" noProof="0" smtClean="0"/>
-              <a:t>08-10-26</a:t>
+              <a:t>09-10-26</a:t>
             </a:fld>
             <a:endParaRPr lang="fr-BE" noProof="0" dirty="0">
               <a:latin typeface="Segoe UI Symbol" panose="020B0502040204020203" pitchFamily="34" charset="0"/>
@@ -1957,8 +1957,8 @@
           </a:p>
         </p:txBody>
       </p:sp>
-      <mc:AlternateContent xmlns:mc="http://schemas.openxmlformats.org/markup-compatibility/2006">
-        <mc:Choice xmlns:a14="http://schemas.microsoft.com/office/drawing/2010/main" Requires="a14">
+      <mc:AlternateContent xmlns:mc="http://schemas.openxmlformats.org/markup-compatibility/2006" xmlns:a14="http://schemas.microsoft.com/office/drawing/2010/main">
+        <mc:Choice Requires="a14">
           <p:sp>
             <p:nvSpPr>
               <p:cNvPr id="5" name="Content Placeholder 4">
@@ -2078,7 +2078,7 @@
             </p:txBody>
           </p:sp>
         </mc:Choice>
-        <mc:Fallback>
+        <mc:Fallback xmlns="">
           <p:sp>
             <p:nvSpPr>
               <p:cNvPr id="5" name="Content Placeholder 4">
@@ -2122,8 +2122,8 @@
           </p:sp>
         </mc:Fallback>
       </mc:AlternateContent>
-      <mc:AlternateContent xmlns:mc="http://schemas.openxmlformats.org/markup-compatibility/2006">
-        <mc:Choice xmlns:a14="http://schemas.microsoft.com/office/drawing/2010/main" Requires="a14">
+      <mc:AlternateContent xmlns:mc="http://schemas.openxmlformats.org/markup-compatibility/2006" xmlns:a14="http://schemas.microsoft.com/office/drawing/2010/main">
+        <mc:Choice Requires="a14">
           <p:sp>
             <p:nvSpPr>
               <p:cNvPr id="6" name="TextBox 5">
@@ -2273,7 +2273,7 @@
             </p:txBody>
           </p:sp>
         </mc:Choice>
-        <mc:Fallback>
+        <mc:Fallback xmlns="">
           <p:sp>
             <p:nvSpPr>
               <p:cNvPr id="6" name="TextBox 5">
@@ -2520,8 +2520,8 @@
           </a:fontRef>
         </p:style>
       </p:cxnSp>
-      <mc:AlternateContent xmlns:mc="http://schemas.openxmlformats.org/markup-compatibility/2006">
-        <mc:Choice xmlns:a14="http://schemas.microsoft.com/office/drawing/2010/main" Requires="a14">
+      <mc:AlternateContent xmlns:mc="http://schemas.openxmlformats.org/markup-compatibility/2006" xmlns:a14="http://schemas.microsoft.com/office/drawing/2010/main">
+        <mc:Choice Requires="a14">
           <p:sp>
             <p:nvSpPr>
               <p:cNvPr id="13" name="Content Placeholder 4">
@@ -2923,7 +2923,7 @@
             </p:txBody>
           </p:sp>
         </mc:Choice>
-        <mc:Fallback>
+        <mc:Fallback xmlns="">
           <p:sp>
             <p:nvSpPr>
               <p:cNvPr id="13" name="Content Placeholder 4">
@@ -3167,7 +3167,7 @@
           <a:p>
             <a:fld id="{CA9A9924-1784-4044-A2E4-3606370E1BB6}" type="datetime1">
               <a:rPr lang="fr-BE" noProof="0" smtClean="0"/>
-              <a:t>08/10/2026</a:t>
+              <a:t>09-10-26</a:t>
             </a:fld>
             <a:endParaRPr lang="fr-BE" noProof="0" dirty="0">
               <a:latin typeface="Segoe UI Symbol" panose="020B0502040204020203" pitchFamily="34" charset="0"/>
@@ -3213,8 +3213,8 @@
           </a:p>
         </p:txBody>
       </p:sp>
-      <mc:AlternateContent xmlns:mc="http://schemas.openxmlformats.org/markup-compatibility/2006">
-        <mc:Choice xmlns:a14="http://schemas.microsoft.com/office/drawing/2010/main" Requires="a14">
+      <mc:AlternateContent xmlns:mc="http://schemas.openxmlformats.org/markup-compatibility/2006" xmlns:a14="http://schemas.microsoft.com/office/drawing/2010/main">
+        <mc:Choice Requires="a14">
           <p:sp>
             <p:nvSpPr>
               <p:cNvPr id="5" name="Content Placeholder 4">
@@ -3512,7 +3512,7 @@
             </p:txBody>
           </p:sp>
         </mc:Choice>
-        <mc:Fallback>
+        <mc:Fallback xmlns="">
           <p:sp>
             <p:nvSpPr>
               <p:cNvPr id="5" name="Content Placeholder 4">
@@ -5050,7 +5050,7 @@
           <a:p>
             <a:fld id="{CA9A9924-1784-4044-A2E4-3606370E1BB6}" type="datetime1">
               <a:rPr lang="fr-BE" noProof="0" smtClean="0"/>
-              <a:t>08-10-26</a:t>
+              <a:t>09-10-26</a:t>
             </a:fld>
             <a:endParaRPr lang="fr-BE" noProof="0" dirty="0">
               <a:latin typeface="Segoe UI Symbol" panose="020B0502040204020203" pitchFamily="34" charset="0"/>
@@ -5385,7 +5385,7 @@
           <a:p>
             <a:fld id="{CA9A9924-1784-4044-A2E4-3606370E1BB6}" type="datetime1">
               <a:rPr lang="fr-BE" noProof="0" smtClean="0"/>
-              <a:t>08/10/2026</a:t>
+              <a:t>09-10-26</a:t>
             </a:fld>
             <a:endParaRPr lang="fr-BE" noProof="0" dirty="0">
               <a:latin typeface="Segoe UI Symbol" panose="020B0502040204020203" pitchFamily="34" charset="0"/>
@@ -5431,8 +5431,8 @@
           </a:p>
         </p:txBody>
       </p:sp>
-      <mc:AlternateContent xmlns:mc="http://schemas.openxmlformats.org/markup-compatibility/2006">
-        <mc:Choice xmlns:a14="http://schemas.microsoft.com/office/drawing/2010/main" Requires="a14">
+      <mc:AlternateContent xmlns:mc="http://schemas.openxmlformats.org/markup-compatibility/2006" xmlns:a14="http://schemas.microsoft.com/office/drawing/2010/main">
+        <mc:Choice Requires="a14">
           <p:sp>
             <p:nvSpPr>
               <p:cNvPr id="5" name="Content Placeholder 4">
@@ -5807,7 +5807,7 @@
             </p:txBody>
           </p:sp>
         </mc:Choice>
-        <mc:Fallback>
+        <mc:Fallback xmlns="">
           <p:sp>
             <p:nvSpPr>
               <p:cNvPr id="5" name="Content Placeholder 4">
@@ -6073,7 +6073,7 @@
           <a:p>
             <a:fld id="{CA9A9924-1784-4044-A2E4-3606370E1BB6}" type="datetime1">
               <a:rPr lang="fr-BE" noProof="0" smtClean="0"/>
-              <a:t>08/10/2026</a:t>
+              <a:t>09-10-26</a:t>
             </a:fld>
             <a:endParaRPr lang="fr-BE" noProof="0" dirty="0">
               <a:latin typeface="Segoe UI Symbol" panose="020B0502040204020203" pitchFamily="34" charset="0"/>
@@ -6155,8 +6155,8 @@
           </a:prstGeom>
         </p:spPr>
       </p:pic>
-      <mc:AlternateContent xmlns:mc="http://schemas.openxmlformats.org/markup-compatibility/2006">
-        <mc:Choice xmlns:a14="http://schemas.microsoft.com/office/drawing/2010/main" Requires="a14">
+      <mc:AlternateContent xmlns:mc="http://schemas.openxmlformats.org/markup-compatibility/2006" xmlns:a14="http://schemas.microsoft.com/office/drawing/2010/main">
+        <mc:Choice Requires="a14">
           <p:sp>
             <p:nvSpPr>
               <p:cNvPr id="12" name="TextBox 11">
@@ -6185,6 +6185,7 @@
               </a:bodyPr>
               <a:lstStyle/>
               <a:p>
+                <a:pPr/>
                 <a14:m>
                   <m:oMathPara xmlns:m="http://schemas.openxmlformats.org/officeDocument/2006/math">
                     <m:oMath>
@@ -6227,6 +6228,7 @@
                 </a:endParaRPr>
               </a:p>
               <a:p>
+                <a:pPr/>
                 <a14:m>
                   <m:oMathPara xmlns:m="http://schemas.openxmlformats.org/officeDocument/2006/math">
                     <m:oMath>
@@ -6287,7 +6289,7 @@
             </p:txBody>
           </p:sp>
         </mc:Choice>
-        <mc:Fallback>
+        <mc:Fallback xmlns="">
           <p:sp>
             <p:nvSpPr>
               <p:cNvPr id="12" name="TextBox 11">
@@ -6332,8 +6334,8 @@
           </p:sp>
         </mc:Fallback>
       </mc:AlternateContent>
-      <mc:AlternateContent xmlns:mc="http://schemas.openxmlformats.org/markup-compatibility/2006">
-        <mc:Choice xmlns:a14="http://schemas.microsoft.com/office/drawing/2010/main" Requires="a14">
+      <mc:AlternateContent xmlns:mc="http://schemas.openxmlformats.org/markup-compatibility/2006" xmlns:a14="http://schemas.microsoft.com/office/drawing/2010/main">
+        <mc:Choice Requires="a14">
           <p:sp>
             <p:nvSpPr>
               <p:cNvPr id="6" name="TextBox 5">
@@ -6479,7 +6481,7 @@
             </p:txBody>
           </p:sp>
         </mc:Choice>
-        <mc:Fallback>
+        <mc:Fallback xmlns="">
           <p:sp>
             <p:nvSpPr>
               <p:cNvPr id="6" name="TextBox 5">
@@ -6621,7 +6623,7 @@
           <a:p>
             <a:fld id="{CA9A9924-1784-4044-A2E4-3606370E1BB6}" type="datetime1">
               <a:rPr lang="fr-BE" noProof="0" smtClean="0"/>
-              <a:t>08/10/2026</a:t>
+              <a:t>09-10-26</a:t>
             </a:fld>
             <a:endParaRPr lang="fr-BE" noProof="0" dirty="0">
               <a:latin typeface="Segoe UI Symbol" panose="020B0502040204020203" pitchFamily="34" charset="0"/>
@@ -7145,7 +7147,7 @@
           <a:p>
             <a:fld id="{CA9A9924-1784-4044-A2E4-3606370E1BB6}" type="datetime1">
               <a:rPr lang="fr-BE" noProof="0" smtClean="0"/>
-              <a:t>08/10/2026</a:t>
+              <a:t>09-10-26</a:t>
             </a:fld>
             <a:endParaRPr lang="fr-BE" noProof="0" dirty="0">
               <a:latin typeface="Segoe UI Symbol" panose="020B0502040204020203" pitchFamily="34" charset="0"/>
@@ -7418,7 +7420,7 @@
           <a:p>
             <a:fld id="{CA9A9924-1784-4044-A2E4-3606370E1BB6}" type="datetime1">
               <a:rPr lang="fr-BE" noProof="0" smtClean="0"/>
-              <a:t>08-10-26</a:t>
+              <a:t>09-10-26</a:t>
             </a:fld>
             <a:endParaRPr lang="fr-BE" noProof="0" dirty="0">
               <a:latin typeface="Segoe UI Symbol" panose="020B0502040204020203" pitchFamily="34" charset="0"/>
@@ -7772,7 +7774,7 @@
           <a:p>
             <a:fld id="{CA9A9924-1784-4044-A2E4-3606370E1BB6}" type="datetime1">
               <a:rPr lang="en-GB" smtClean="0"/>
-              <a:t>08/10/2026</a:t>
+              <a:t>09/10/2026</a:t>
             </a:fld>
             <a:endParaRPr lang="en-GB" dirty="0">
               <a:latin typeface="Segoe UI Symbol" panose="020B0502040204020203" pitchFamily="34" charset="0"/>
@@ -7928,8 +7930,8 @@
           </a:prstGeom>
         </p:spPr>
       </p:pic>
-      <mc:AlternateContent xmlns:mc="http://schemas.openxmlformats.org/markup-compatibility/2006">
-        <mc:Choice xmlns:a14="http://schemas.microsoft.com/office/drawing/2010/main" Requires="a14">
+      <mc:AlternateContent xmlns:mc="http://schemas.openxmlformats.org/markup-compatibility/2006" xmlns:a14="http://schemas.microsoft.com/office/drawing/2010/main">
+        <mc:Choice Requires="a14">
           <p:sp>
             <p:nvSpPr>
               <p:cNvPr id="23" name="TextBox 22">
@@ -8031,7 +8033,7 @@
             </p:txBody>
           </p:sp>
         </mc:Choice>
-        <mc:Fallback>
+        <mc:Fallback xmlns="">
           <p:sp>
             <p:nvSpPr>
               <p:cNvPr id="23" name="TextBox 22">
@@ -8301,7 +8303,7 @@
           <a:p>
             <a:fld id="{CA9A9924-1784-4044-A2E4-3606370E1BB6}" type="datetime1">
               <a:rPr lang="en-GB" smtClean="0"/>
-              <a:t>08/10/2026</a:t>
+              <a:t>09/10/2026</a:t>
             </a:fld>
             <a:endParaRPr lang="en-GB" dirty="0">
               <a:latin typeface="Segoe UI Symbol" panose="020B0502040204020203" pitchFamily="34" charset="0"/>
@@ -8347,8 +8349,8 @@
           </a:p>
         </p:txBody>
       </p:sp>
-      <mc:AlternateContent xmlns:mc="http://schemas.openxmlformats.org/markup-compatibility/2006">
-        <mc:Choice xmlns:a14="http://schemas.microsoft.com/office/drawing/2010/main" Requires="a14">
+      <mc:AlternateContent xmlns:mc="http://schemas.openxmlformats.org/markup-compatibility/2006" xmlns:a14="http://schemas.microsoft.com/office/drawing/2010/main">
+        <mc:Choice Requires="a14">
           <p:sp>
             <p:nvSpPr>
               <p:cNvPr id="23" name="TextBox 22">
@@ -8466,7 +8468,7 @@
             </p:txBody>
           </p:sp>
         </mc:Choice>
-        <mc:Fallback>
+        <mc:Fallback xmlns="">
           <p:sp>
             <p:nvSpPr>
               <p:cNvPr id="23" name="TextBox 22">
@@ -8925,7 +8927,7 @@
           <a:p>
             <a:fld id="{CA9A9924-1784-4044-A2E4-3606370E1BB6}" type="datetime1">
               <a:rPr lang="fr-BE" noProof="0" smtClean="0"/>
-              <a:t>08/10/2026</a:t>
+              <a:t>09-10-26</a:t>
             </a:fld>
             <a:endParaRPr lang="fr-BE" noProof="0" dirty="0">
               <a:latin typeface="Segoe UI Symbol" panose="020B0502040204020203" pitchFamily="34" charset="0"/>
@@ -9296,7 +9298,7 @@
           <a:p>
             <a:fld id="{CA9A9924-1784-4044-A2E4-3606370E1BB6}" type="datetime1">
               <a:rPr lang="en-GB" smtClean="0"/>
-              <a:t>08/10/2026</a:t>
+              <a:t>09/10/2026</a:t>
             </a:fld>
             <a:endParaRPr lang="en-GB" dirty="0">
               <a:latin typeface="Segoe UI Symbol" panose="020B0502040204020203" pitchFamily="34" charset="0"/>
@@ -9342,8 +9344,8 @@
           </a:p>
         </p:txBody>
       </p:sp>
-      <mc:AlternateContent xmlns:mc="http://schemas.openxmlformats.org/markup-compatibility/2006">
-        <mc:Choice xmlns:a14="http://schemas.microsoft.com/office/drawing/2010/main" Requires="a14">
+      <mc:AlternateContent xmlns:mc="http://schemas.openxmlformats.org/markup-compatibility/2006" xmlns:a14="http://schemas.microsoft.com/office/drawing/2010/main">
+        <mc:Choice Requires="a14">
           <p:sp>
             <p:nvSpPr>
               <p:cNvPr id="23" name="TextBox 22">
@@ -9461,7 +9463,7 @@
             </p:txBody>
           </p:sp>
         </mc:Choice>
-        <mc:Fallback>
+        <mc:Fallback xmlns="">
           <p:sp>
             <p:nvSpPr>
               <p:cNvPr id="23" name="TextBox 22">
@@ -9826,7 +9828,7 @@
           <a:p>
             <a:fld id="{CA9A9924-1784-4044-A2E4-3606370E1BB6}" type="datetime1">
               <a:rPr lang="fr-BE" noProof="0" smtClean="0"/>
-              <a:t>08-10-26</a:t>
+              <a:t>09-10-26</a:t>
             </a:fld>
             <a:endParaRPr lang="fr-BE" noProof="0" dirty="0">
               <a:latin typeface="Segoe UI Symbol" panose="020B0502040204020203" pitchFamily="34" charset="0"/>
@@ -10173,7 +10175,7 @@
           <a:p>
             <a:fld id="{CA9A9924-1784-4044-A2E4-3606370E1BB6}" type="datetime1">
               <a:rPr lang="fr-BE" noProof="0" smtClean="0"/>
-              <a:t>08/10/2026</a:t>
+              <a:t>09-10-26</a:t>
             </a:fld>
             <a:endParaRPr lang="fr-BE" noProof="0" dirty="0">
               <a:latin typeface="Segoe UI Symbol" panose="020B0502040204020203" pitchFamily="34" charset="0"/>
@@ -10601,7 +10603,7 @@
           <a:p>
             <a:fld id="{CA9A9924-1784-4044-A2E4-3606370E1BB6}" type="datetime1">
               <a:rPr lang="fr-BE" noProof="0" smtClean="0"/>
-              <a:t>08-10-26</a:t>
+              <a:t>09-10-26</a:t>
             </a:fld>
             <a:endParaRPr lang="fr-BE" noProof="0" dirty="0">
               <a:latin typeface="Segoe UI Symbol" panose="020B0502040204020203" pitchFamily="34" charset="0"/>
@@ -10952,7 +10954,7 @@
           <a:p>
             <a:fld id="{CA9A9924-1784-4044-A2E4-3606370E1BB6}" type="datetime1">
               <a:rPr lang="fr-BE" noProof="0" smtClean="0"/>
-              <a:t>08-10-26</a:t>
+              <a:t>09-10-26</a:t>
             </a:fld>
             <a:endParaRPr lang="fr-BE" noProof="0" dirty="0">
               <a:latin typeface="Segoe UI Symbol" panose="020B0502040204020203" pitchFamily="34" charset="0"/>
@@ -11249,8 +11251,8 @@
           </a:p>
         </p:txBody>
       </p:sp>
-      <mc:AlternateContent xmlns:mc="http://schemas.openxmlformats.org/markup-compatibility/2006">
-        <mc:Choice xmlns:a14="http://schemas.microsoft.com/office/drawing/2010/main" Requires="a14">
+      <mc:AlternateContent xmlns:mc="http://schemas.openxmlformats.org/markup-compatibility/2006" xmlns:a14="http://schemas.microsoft.com/office/drawing/2010/main">
+        <mc:Choice Requires="a14">
           <p:sp>
             <p:nvSpPr>
               <p:cNvPr id="15" name="TextBox 14">
@@ -11389,7 +11391,7 @@
             </p:txBody>
           </p:sp>
         </mc:Choice>
-        <mc:Fallback>
+        <mc:Fallback xmlns="">
           <p:sp>
             <p:nvSpPr>
               <p:cNvPr id="15" name="TextBox 14">
@@ -11522,7 +11524,7 @@
           <a:p>
             <a:fld id="{CA9A9924-1784-4044-A2E4-3606370E1BB6}" type="datetime1">
               <a:rPr lang="fr-BE" noProof="0" smtClean="0"/>
-              <a:t>08-10-26</a:t>
+              <a:t>09-10-26</a:t>
             </a:fld>
             <a:endParaRPr lang="fr-BE" noProof="0" dirty="0">
               <a:latin typeface="Segoe UI Symbol" panose="020B0502040204020203" pitchFamily="34" charset="0"/>
@@ -11869,7 +11871,7 @@
           <a:p>
             <a:fld id="{CA9A9924-1784-4044-A2E4-3606370E1BB6}" type="datetime1">
               <a:rPr lang="fr-BE" noProof="0" smtClean="0"/>
-              <a:t>08/10/2026</a:t>
+              <a:t>09-10-26</a:t>
             </a:fld>
             <a:endParaRPr lang="fr-BE" noProof="0" dirty="0">
               <a:latin typeface="Segoe UI Symbol" panose="020B0502040204020203" pitchFamily="34" charset="0"/>
@@ -11915,8 +11917,8 @@
           </a:p>
         </p:txBody>
       </p:sp>
-      <mc:AlternateContent xmlns:mc="http://schemas.openxmlformats.org/markup-compatibility/2006">
-        <mc:Choice xmlns:a14="http://schemas.microsoft.com/office/drawing/2010/main" Requires="a14">
+      <mc:AlternateContent xmlns:mc="http://schemas.openxmlformats.org/markup-compatibility/2006" xmlns:a14="http://schemas.microsoft.com/office/drawing/2010/main">
+        <mc:Choice Requires="a14">
           <p:sp>
             <p:nvSpPr>
               <p:cNvPr id="5" name="Content Placeholder 4">
@@ -12122,7 +12124,7 @@
             </p:txBody>
           </p:sp>
         </mc:Choice>
-        <mc:Fallback>
+        <mc:Fallback xmlns="">
           <p:sp>
             <p:nvSpPr>
               <p:cNvPr id="5" name="Content Placeholder 4">
@@ -12254,7 +12256,7 @@
           <a:p>
             <a:fld id="{CA9A9924-1784-4044-A2E4-3606370E1BB6}" type="datetime1">
               <a:rPr lang="fr-BE" noProof="0" smtClean="0"/>
-              <a:t>08-10-26</a:t>
+              <a:t>09-10-26</a:t>
             </a:fld>
             <a:endParaRPr lang="fr-BE" noProof="0" dirty="0">
               <a:latin typeface="Segoe UI Symbol" panose="020B0502040204020203" pitchFamily="34" charset="0"/>
@@ -12605,7 +12607,7 @@
           <a:p>
             <a:fld id="{CA9A9924-1784-4044-A2E4-3606370E1BB6}" type="datetime1">
               <a:rPr lang="en-GB" smtClean="0"/>
-              <a:t>08/10/2026</a:t>
+              <a:t>09/10/2026</a:t>
             </a:fld>
             <a:endParaRPr lang="en-GB" dirty="0">
               <a:latin typeface="Segoe UI Symbol" panose="020B0502040204020203" pitchFamily="34" charset="0"/>
@@ -13005,6 +13007,73 @@
               <a:rPr lang="en-GB" sz="2200" dirty="0"/>
               <a:t>)</a:t>
             </a:r>
+          </a:p>
+          <a:p>
+            <a:r>
+              <a:rPr lang="en-GB" sz="2200" dirty="0"/>
+              <a:t>Idée pour validation : utiliser </a:t>
+            </a:r>
+            <a:r>
+              <a:rPr lang="en-GB" sz="2200" dirty="0" err="1"/>
+              <a:t>mesures</a:t>
+            </a:r>
+            <a:r>
+              <a:rPr lang="en-GB" sz="2200" dirty="0"/>
+              <a:t> </a:t>
+            </a:r>
+            <a:r>
+              <a:rPr lang="en-GB" sz="2200" dirty="0" err="1"/>
+              <a:t>depuis</a:t>
+            </a:r>
+            <a:r>
+              <a:rPr lang="en-GB" sz="2200" dirty="0"/>
+              <a:t> </a:t>
+            </a:r>
+            <a:r>
+              <a:rPr lang="en-GB" sz="2200" dirty="0" err="1"/>
+              <a:t>accéléro</a:t>
+            </a:r>
+            <a:r>
+              <a:rPr lang="en-GB" sz="2200" dirty="0"/>
+              <a:t> / vel. Sensor pour </a:t>
+            </a:r>
+            <a:r>
+              <a:rPr lang="en-GB" sz="2200" dirty="0" err="1"/>
+              <a:t>reconstruire</a:t>
+            </a:r>
+            <a:r>
+              <a:rPr lang="en-GB" sz="2200" dirty="0"/>
+              <a:t> un </a:t>
+            </a:r>
+            <a:r>
+              <a:rPr lang="en-GB" sz="2200" dirty="0" err="1"/>
+              <a:t>profil</a:t>
+            </a:r>
+            <a:r>
+              <a:rPr lang="en-GB" sz="2200" dirty="0"/>
+              <a:t> de Vitesse &amp; </a:t>
+            </a:r>
+            <a:r>
+              <a:rPr lang="en-GB" sz="2200" dirty="0" err="1"/>
+              <a:t>mettre</a:t>
+            </a:r>
+            <a:r>
+              <a:rPr lang="en-GB" sz="2200" dirty="0"/>
+              <a:t> dans le </a:t>
+            </a:r>
+            <a:r>
+              <a:rPr lang="en-GB" sz="2200" dirty="0" err="1"/>
+              <a:t>calcul</a:t>
+            </a:r>
+            <a:r>
+              <a:rPr lang="en-GB" sz="2200" dirty="0"/>
+              <a:t> de consommation </a:t>
+            </a:r>
+            <a:r>
+              <a:rPr lang="en-GB" sz="2200"/>
+              <a:t>pour comparer</a:t>
+            </a:r>
+            <a:endParaRPr lang="en-GB" sz="2200" dirty="0"/>
           </a:p>
         </p:txBody>
       </p:sp>
@@ -13094,7 +13163,7 @@
           <a:p>
             <a:fld id="{CA9A9924-1784-4044-A2E4-3606370E1BB6}" type="datetime1">
               <a:rPr lang="fr-BE" noProof="0" smtClean="0"/>
-              <a:t>08/10/2026</a:t>
+              <a:t>09-10-26</a:t>
             </a:fld>
             <a:endParaRPr lang="fr-BE" noProof="0" dirty="0">
               <a:latin typeface="Segoe UI Symbol" panose="020B0502040204020203" pitchFamily="34" charset="0"/>
@@ -13336,7 +13405,7 @@
           <a:p>
             <a:fld id="{CA9A9924-1784-4044-A2E4-3606370E1BB6}" type="datetime1">
               <a:rPr lang="fr-BE" noProof="0" smtClean="0"/>
-              <a:t>08-10-26</a:t>
+              <a:t>09-10-26</a:t>
             </a:fld>
             <a:endParaRPr lang="fr-BE" noProof="0" dirty="0">
               <a:latin typeface="Segoe UI Symbol" panose="020B0502040204020203" pitchFamily="34" charset="0"/>
@@ -13680,7 +13749,7 @@
           <a:p>
             <a:fld id="{CA9A9924-1784-4044-A2E4-3606370E1BB6}" type="datetime1">
               <a:rPr lang="en-GB" smtClean="0"/>
-              <a:t>08/10/2026</a:t>
+              <a:t>09/10/2026</a:t>
             </a:fld>
             <a:endParaRPr lang="en-GB" dirty="0">
               <a:latin typeface="Segoe UI Symbol" panose="020B0502040204020203" pitchFamily="34" charset="0"/>
@@ -14327,7 +14396,7 @@
           <a:p>
             <a:fld id="{CA9A9924-1784-4044-A2E4-3606370E1BB6}" type="datetime1">
               <a:rPr lang="en-GB" smtClean="0"/>
-              <a:t>08/10/2026</a:t>
+              <a:t>09/10/2026</a:t>
             </a:fld>
             <a:endParaRPr lang="en-GB" dirty="0">
               <a:latin typeface="Segoe UI Symbol" panose="020B0502040204020203" pitchFamily="34" charset="0"/>
@@ -14373,8 +14442,8 @@
           </a:p>
         </p:txBody>
       </p:sp>
-      <mc:AlternateContent xmlns:mc="http://schemas.openxmlformats.org/markup-compatibility/2006">
-        <mc:Choice xmlns:a14="http://schemas.microsoft.com/office/drawing/2010/main" Requires="a14">
+      <mc:AlternateContent xmlns:mc="http://schemas.openxmlformats.org/markup-compatibility/2006" xmlns:a14="http://schemas.microsoft.com/office/drawing/2010/main">
+        <mc:Choice Requires="a14">
           <p:sp>
             <p:nvSpPr>
               <p:cNvPr id="8" name="Content Placeholder 7">
@@ -14898,7 +14967,7 @@
             </p:txBody>
           </p:sp>
         </mc:Choice>
-        <mc:Fallback>
+        <mc:Fallback xmlns="">
           <p:sp>
             <p:nvSpPr>
               <p:cNvPr id="8" name="Content Placeholder 7">
@@ -15002,8 +15071,8 @@
           </a:p>
         </p:txBody>
       </p:sp>
-      <mc:AlternateContent xmlns:mc="http://schemas.openxmlformats.org/markup-compatibility/2006">
-        <mc:Choice xmlns:a14="http://schemas.microsoft.com/office/drawing/2010/main" Requires="a14">
+      <mc:AlternateContent xmlns:mc="http://schemas.openxmlformats.org/markup-compatibility/2006" xmlns:a14="http://schemas.microsoft.com/office/drawing/2010/main">
+        <mc:Choice Requires="a14">
           <p:sp>
             <p:nvSpPr>
               <p:cNvPr id="13" name="TextBox 12">
@@ -15099,7 +15168,7 @@
             </p:txBody>
           </p:sp>
         </mc:Choice>
-        <mc:Fallback>
+        <mc:Fallback xmlns="">
           <p:sp>
             <p:nvSpPr>
               <p:cNvPr id="13" name="TextBox 12">
@@ -15144,8 +15213,8 @@
           </p:sp>
         </mc:Fallback>
       </mc:AlternateContent>
-      <mc:AlternateContent xmlns:mc="http://schemas.openxmlformats.org/markup-compatibility/2006">
-        <mc:Choice xmlns:a14="http://schemas.microsoft.com/office/drawing/2010/main" Requires="a14">
+      <mc:AlternateContent xmlns:mc="http://schemas.openxmlformats.org/markup-compatibility/2006" xmlns:a14="http://schemas.microsoft.com/office/drawing/2010/main">
+        <mc:Choice Requires="a14">
           <p:sp>
             <p:nvSpPr>
               <p:cNvPr id="15" name="TextBox 14">
@@ -15398,7 +15467,7 @@
             </p:txBody>
           </p:sp>
         </mc:Choice>
-        <mc:Fallback>
+        <mc:Fallback xmlns="">
           <p:sp>
             <p:nvSpPr>
               <p:cNvPr id="15" name="TextBox 14">
@@ -15496,8 +15565,8 @@
           </a:p>
         </p:txBody>
       </p:sp>
-      <mc:AlternateContent xmlns:mc="http://schemas.openxmlformats.org/markup-compatibility/2006">
-        <mc:Choice xmlns:a14="http://schemas.microsoft.com/office/drawing/2010/main" Requires="a14">
+      <mc:AlternateContent xmlns:mc="http://schemas.openxmlformats.org/markup-compatibility/2006" xmlns:a14="http://schemas.microsoft.com/office/drawing/2010/main">
+        <mc:Choice Requires="a14">
           <p:sp>
             <p:nvSpPr>
               <p:cNvPr id="21" name="TextBox 20">
@@ -15634,7 +15703,7 @@
             </p:txBody>
           </p:sp>
         </mc:Choice>
-        <mc:Fallback>
+        <mc:Fallback xmlns="">
           <p:sp>
             <p:nvSpPr>
               <p:cNvPr id="21" name="TextBox 20">
@@ -15780,7 +15849,7 @@
           <a:p>
             <a:fld id="{CA9A9924-1784-4044-A2E4-3606370E1BB6}" type="datetime1">
               <a:rPr lang="en-GB" smtClean="0"/>
-              <a:t>08/10/2026</a:t>
+              <a:t>09/10/2026</a:t>
             </a:fld>
             <a:endParaRPr lang="en-GB" dirty="0">
               <a:latin typeface="Segoe UI Symbol" panose="020B0502040204020203" pitchFamily="34" charset="0"/>
@@ -15826,8 +15895,8 @@
           </a:p>
         </p:txBody>
       </p:sp>
-      <mc:AlternateContent xmlns:mc="http://schemas.openxmlformats.org/markup-compatibility/2006">
-        <mc:Choice xmlns:a14="http://schemas.microsoft.com/office/drawing/2010/main" Requires="a14">
+      <mc:AlternateContent xmlns:mc="http://schemas.openxmlformats.org/markup-compatibility/2006" xmlns:a14="http://schemas.microsoft.com/office/drawing/2010/main">
+        <mc:Choice Requires="a14">
           <p:sp>
             <p:nvSpPr>
               <p:cNvPr id="6" name="Content Placeholder 5">
@@ -16449,7 +16518,7 @@
             </p:txBody>
           </p:sp>
         </mc:Choice>
-        <mc:Fallback>
+        <mc:Fallback xmlns="">
           <p:sp>
             <p:nvSpPr>
               <p:cNvPr id="6" name="Content Placeholder 5">
@@ -18159,8 +18228,8 @@
             </a:p>
           </p:txBody>
         </p:sp>
-        <mc:AlternateContent xmlns:mc="http://schemas.openxmlformats.org/markup-compatibility/2006">
-          <mc:Choice xmlns:a14="http://schemas.microsoft.com/office/drawing/2010/main" Requires="a14">
+        <mc:AlternateContent xmlns:mc="http://schemas.openxmlformats.org/markup-compatibility/2006" xmlns:a14="http://schemas.microsoft.com/office/drawing/2010/main">
+          <mc:Choice Requires="a14">
             <p:sp>
               <p:nvSpPr>
                 <p:cNvPr id="22" name="TextBox 21">
@@ -18189,6 +18258,7 @@
                 </a:bodyPr>
                 <a:lstStyle/>
                 <a:p>
+                  <a:pPr/>
                   <a14:m>
                     <m:oMathPara xmlns:m="http://schemas.openxmlformats.org/officeDocument/2006/math">
                       <m:oMath>
@@ -18312,7 +18382,7 @@
               </p:txBody>
             </p:sp>
           </mc:Choice>
-          <mc:Fallback>
+          <mc:Fallback xmlns="">
             <p:sp>
               <p:nvSpPr>
                 <p:cNvPr id="22" name="TextBox 21">
@@ -18572,7 +18642,7 @@
           <a:p>
             <a:fld id="{CA9A9924-1784-4044-A2E4-3606370E1BB6}" type="datetime1">
               <a:rPr lang="en-GB" smtClean="0"/>
-              <a:t>08/10/2026</a:t>
+              <a:t>09/10/2026</a:t>
             </a:fld>
             <a:endParaRPr lang="en-GB" dirty="0">
               <a:latin typeface="Segoe UI Symbol" panose="020B0502040204020203" pitchFamily="34" charset="0"/>
@@ -18903,8 +18973,8 @@
           </a:p>
         </p:txBody>
       </p:sp>
-      <mc:AlternateContent xmlns:mc="http://schemas.openxmlformats.org/markup-compatibility/2006">
-        <mc:Choice xmlns:a14="http://schemas.microsoft.com/office/drawing/2010/main" Requires="a14">
+      <mc:AlternateContent xmlns:mc="http://schemas.openxmlformats.org/markup-compatibility/2006" xmlns:a14="http://schemas.microsoft.com/office/drawing/2010/main">
+        <mc:Choice Requires="a14">
           <p:sp>
             <p:nvSpPr>
               <p:cNvPr id="7" name="TextBox 6">
@@ -19010,7 +19080,7 @@
             </p:txBody>
           </p:sp>
         </mc:Choice>
-        <mc:Fallback>
+        <mc:Fallback xmlns="">
           <p:sp>
             <p:nvSpPr>
               <p:cNvPr id="7" name="TextBox 6">
@@ -19236,8 +19306,8 @@
           </a:prstGeom>
         </p:spPr>
       </p:pic>
-      <mc:AlternateContent xmlns:mc="http://schemas.openxmlformats.org/markup-compatibility/2006">
-        <mc:Choice xmlns:a14="http://schemas.microsoft.com/office/drawing/2010/main" Requires="a14">
+      <mc:AlternateContent xmlns:mc="http://schemas.openxmlformats.org/markup-compatibility/2006" xmlns:a14="http://schemas.microsoft.com/office/drawing/2010/main">
+        <mc:Choice Requires="a14">
           <p:sp>
             <p:nvSpPr>
               <p:cNvPr id="30" name="TextBox 29">
@@ -19339,7 +19409,7 @@
             </p:txBody>
           </p:sp>
         </mc:Choice>
-        <mc:Fallback>
+        <mc:Fallback xmlns="">
           <p:sp>
             <p:nvSpPr>
               <p:cNvPr id="30" name="TextBox 29">
@@ -19529,7 +19599,7 @@
           <a:p>
             <a:fld id="{03B5460E-E22B-4565-90E6-E4027A0F32B5}" type="datetime1">
               <a:rPr lang="fr-BE" noProof="0" smtClean="0"/>
-              <a:t>08/10/2026</a:t>
+              <a:t>09-10-26</a:t>
             </a:fld>
             <a:endParaRPr lang="fr-BE" noProof="0" dirty="0">
               <a:latin typeface="Segoe UI Symbol" panose="020B0502040204020203" pitchFamily="34" charset="0"/>

</xml_diff>